<commit_message>
Toolbox talk v1.1 with speaker-note script; retire 03c booklet; review service renews by payment link
Deck: script moved into the pptx speaker notes (v1.1, issued 2 Sep 2026);
03c delivery script booklet retired from the pack, catalogue, sign-offs
and fulfilment. Pack is now five documents.

Review service: no Stripe subscription. First year is charged with the
order (one-off line in Checkout); renewal is a payment link the office
sends from the new admin reviews queue ~30 days before the due date.
Nothing is charged automatically; unpaid reviews lapse at the due date.
Renewal payment pins the next due date twelve months from the previous
due date, not the payment date. Invoice orders activate the review at
issue (fixes review staying 'None' on invoiced orders). Wizard pins the
policy review cycle to 12 months when the service is selected. Emails
and terms reworded to match.
</commit_message>
<xml_diff>
--- a/assets/fulfilment/nivha_pack_03_toolbox_talk_condensed.pptx
+++ b/assets/fulfilment/nivha_pack_03_toolbox_talk_condensed.pptx
@@ -519,11 +519,177 @@
           <a:lstStyle/>
           <a:p>
             <a:r>
-              <a:rPr lang="en-US" dirty="0"/>
-              <a:t>This slide is for whoever prepares the deck. It is not part of the talk.
-Work down the checklist, then delete this slide.</a:t>
-            </a:r>
-            <a:endParaRPr lang="en-US" dirty="0"/>
+              <a:rPr lang="en-GB" sz="1000" b="1" dirty="0"/>
+              <a:t>How to run this talk — preparation notes</a:t>
+            </a:r>
+          </a:p>
+          <a:p>
+            <a:r>
+              <a:rPr lang="en-GB" sz="1000" dirty="0"/>
+              <a:t>These speaker notes carry the full delivery script. Each slide’s notes hold the words for that slide — read them aloud, or use your own words. To work from paper, print the notes pages (File → Print → Notes pages).</a:t>
+            </a:r>
+          </a:p>
+          <a:p>
+            <a:r>
+              <a:rPr lang="en-GB" sz="1000" b="1" dirty="0"/>
+              <a:t>What you need on the day</a:t>
+            </a:r>
+          </a:p>
+          <a:p>
+            <a:r>
+              <a:rPr lang="en-GB" sz="1000" dirty="0"/>
+              <a:t>The slide deck, on a screen everyone can see</a:t>
+            </a:r>
+          </a:p>
+          <a:p>
+            <a:r>
+              <a:rPr lang="en-GB" sz="1000" dirty="0"/>
+              <a:t>Sound, tested before people arrive — there is a short film in slide 7</a:t>
+            </a:r>
+          </a:p>
+          <a:p>
+            <a:r>
+              <a:rPr lang="en-GB" sz="1000" dirty="0"/>
+              <a:t>The printed sign-off sheet, and a pen that works</a:t>
+            </a:r>
+          </a:p>
+          <a:p>
+            <a:r>
+              <a:rPr lang="en-GB" sz="1000" dirty="0"/>
+              <a:t>These speaker notes, printed as notes pages — or a second screen showing presenter view</a:t>
+            </a:r>
+          </a:p>
+          <a:p>
+            <a:r>
+              <a:rPr lang="en-GB" sz="1000" b="1" dirty="0"/>
+              <a:t>Before you start</a:t>
+            </a:r>
+          </a:p>
+          <a:p>
+            <a:r>
+              <a:rPr lang="en-GB" sz="1000" dirty="0"/>
+              <a:t>You are not expected to be an expert on drugs, alcohol or testing. You are expected to read this out clearly, keep the room calm, and know what to do with a question you cannot answer. That last part is under “The one rule for questions” below, and it is the most important part of these notes.</a:t>
+            </a:r>
+          </a:p>
+          <a:p>
+            <a:r>
+              <a:rPr lang="en-GB" sz="1000" b="1" dirty="0"/>
+              <a:t>Your versions of two slides</a:t>
+            </a:r>
+          </a:p>
+          <a:p>
+            <a:r>
+              <a:rPr lang="en-GB" sz="1000" dirty="0"/>
+              <a:t>Two slides come in three versions — Northern Ireland, Republic of Ireland and Great Britain — each labelled in the top right corner.</a:t>
+            </a:r>
+          </a:p>
+          <a:p>
+            <a:r>
+              <a:rPr lang="en-GB" sz="1000" dirty="0"/>
+              <a:t>Keep the one that matches where you operate, delete the other two of each, then delete the instructions slide at the front.</a:t>
+            </a:r>
+          </a:p>
+          <a:p>
+            <a:r>
+              <a:rPr lang="en-GB" sz="1000" dirty="0"/>
+              <a:t>These notes carry the words for all three versions, labelled the same way.</a:t>
+            </a:r>
+          </a:p>
+          <a:p>
+            <a:r>
+              <a:rPr lang="en-GB" sz="1000" b="1" dirty="0"/>
+              <a:t>The room</a:t>
+            </a:r>
+          </a:p>
+          <a:p>
+            <a:r>
+              <a:rPr lang="en-GB" sz="1000" dirty="0"/>
+              <a:t>Somewhere people can sit and see the screen. A canteen out of hours works; a noisy workshop does not.</a:t>
+            </a:r>
+          </a:p>
+          <a:p>
+            <a:r>
+              <a:rPr lang="en-GB" sz="1000" dirty="0"/>
+              <a:t>Turn phones face down rather than banning them — people will want to photograph the support slide.</a:t>
+            </a:r>
+          </a:p>
+          <a:p>
+            <a:r>
+              <a:rPr lang="en-GB" sz="1000" dirty="0"/>
+              <a:t>Test the film on slide 7 with the sound on, before anyone arrives. If there is no internet, use the four moments listed on the slide instead and describe them.</a:t>
+            </a:r>
+          </a:p>
+          <a:p>
+            <a:r>
+              <a:rPr lang="en-GB" sz="1000" dirty="0"/>
+              <a:t>Print the sign-off sheet. Everyone present signs it, including you.</a:t>
+            </a:r>
+          </a:p>
+          <a:p>
+            <a:r>
+              <a:rPr lang="en-GB" sz="1000" b="1" dirty="0"/>
+              <a:t>The timing</a:t>
+            </a:r>
+          </a:p>
+          <a:p>
+            <a:r>
+              <a:rPr lang="en-GB" sz="1000" dirty="0"/>
+              <a:t>The core talk runs about 25 to 35 minutes, including the film and the three questions at the end. The timings against each section are a guide, not a target. If the room is quiet, you will be at the shorter end; if people are asking questions, take the longer end and let them.</a:t>
+            </a:r>
+          </a:p>
+          <a:p>
+            <a:r>
+              <a:rPr lang="en-GB" sz="1000" b="1" dirty="0"/>
+              <a:t>The tone</a:t>
+            </a:r>
+          </a:p>
+          <a:p>
+            <a:r>
+              <a:rPr lang="en-GB" sz="1000" dirty="0"/>
+              <a:t>Safety, not surveillance. Say that early and mean it.</a:t>
+            </a:r>
+          </a:p>
+          <a:p>
+            <a:r>
+              <a:rPr lang="en-GB" sz="1000" dirty="0"/>
+              <a:t>Nobody is in trouble, and this is not an investigation.</a:t>
+            </a:r>
+          </a:p>
+          <a:p>
+            <a:r>
+              <a:rPr lang="en-GB" sz="1000" dirty="0"/>
+              <a:t>Ask people not to use anyone by name as an example, including themselves. Situations, not people.</a:t>
+            </a:r>
+          </a:p>
+          <a:p>
+            <a:r>
+              <a:rPr lang="en-GB" sz="1000" dirty="0"/>
+              <a:t>If someone becomes upset, move on and offer a private word afterwards. Do not make it a discussion.</a:t>
+            </a:r>
+          </a:p>
+          <a:p>
+            <a:r>
+              <a:rPr lang="en-GB" sz="1000" b="1" dirty="0"/>
+              <a:t>The one rule for questions</a:t>
+            </a:r>
+          </a:p>
+          <a:p>
+            <a:r>
+              <a:rPr lang="en-GB" sz="1000" dirty="0"/>
+              <a:t>If you are asked anything you cannot answer — about the science, about someone’s medication, about what would happen in a particular case — park it. Say: “That is a fair question and I am not going to guess at it. I will write it down and get you a proper answer.”</a:t>
+            </a:r>
+          </a:p>
+          <a:p>
+            <a:r>
+              <a:rPr lang="en-GB" sz="1000" dirty="0"/>
+              <a:t>Write the question in the parked questions box on the sign-off sheet and pass the sheet to ⟨Policy owner⟩ after the talk. They resolve it against the policy, or through the organisation’s testing provider arrangements, and the answer comes back to whoever asked.</a:t>
+            </a:r>
+          </a:p>
+          <a:p>
+            <a:r>
+              <a:rPr lang="en-GB" sz="1000" dirty="0"/>
+              <a:t>Never guess. A confident wrong answer about testing is the single most damaging thing that can happen in one of these sessions.</a:t>
+            </a:r>
           </a:p>
         </p:txBody>
       </p:sp>
@@ -608,13 +774,69 @@
           <a:lstStyle/>
           <a:p>
             <a:r>
-              <a:rPr lang="en-US" dirty="0"/>
-              <a:t>Cue: play the film — test the sound before the session starts.
-Cue: before playing, tell people what to watch for: the sealed kit, the swab, the seal, the signature.
-Cue: afterwards ask whether anything was different from what they expected.
-Script booklet, section 7. If there is no internet, describe the four moments instead.</a:t>
-            </a:r>
-            <a:endParaRPr lang="en-US" dirty="0"/>
+              <a:rPr lang="en-GB" sz="1000" b="1" dirty="0"/>
+              <a:t>How testing works — the film · about 5 minutes including the film</a:t>
+            </a:r>
+          </a:p>
+          <a:p>
+            <a:r>
+              <a:rPr lang="en-GB" sz="1000" b="1" dirty="0"/>
+              <a:t>SAY THIS</a:t>
+            </a:r>
+          </a:p>
+          <a:p>
+            <a:r>
+              <a:rPr lang="en-GB" sz="1000" dirty="0"/>
+              <a:t>Rather than describe this, I am going to show you. This is a short film of a mouth swab collection from start to finish.</a:t>
+            </a:r>
+          </a:p>
+          <a:p>
+            <a:r>
+              <a:rPr lang="en-GB" sz="1000" dirty="0"/>
+              <a:t>Before I play it, watch for four moments: the sealed kit being opened in front of the person, how the swab is handled and by whom, the tamper-evident seal going on, and the paperwork being checked and signed. That is the whole procedure.</a:t>
+            </a:r>
+          </a:p>
+          <a:p>
+            <a:r>
+              <a:rPr lang="en-GB" sz="1000" dirty="0"/>
+              <a:t>Nobody in the film is an employee of any client. It is a demonstration.</a:t>
+            </a:r>
+          </a:p>
+          <a:p>
+            <a:r>
+              <a:rPr lang="en-GB" sz="1000" dirty="0"/>
+              <a:t>[Play the film.]</a:t>
+            </a:r>
+          </a:p>
+          <a:p>
+            <a:r>
+              <a:rPr lang="en-GB" sz="1000" dirty="0"/>
+              <a:t>That paper trail has a name — chain of custody — and it sounds like jargon, but it is the best protection you have. From the moment a sample leaves your body there is a record of who had it, when, and what they did with it. It means nobody can suggest your sample got mixed up with somebody else’s or interfered with. And if any link in that chain is broken, the result is not defensible and cannot be used.</a:t>
+            </a:r>
+          </a:p>
+          <a:p>
+            <a:r>
+              <a:rPr lang="en-GB" sz="1000" dirty="0"/>
+              <a:t>You check the details, you sign, and you keep a copy.</a:t>
+            </a:r>
+          </a:p>
+          <a:p>
+            <a:r>
+              <a:rPr lang="en-GB" sz="1000" dirty="0"/>
+              <a:t>If the screen is negative, that is the end of it and you go back to work.</a:t>
+            </a:r>
+          </a:p>
+          <a:p>
+            <a:r>
+              <a:rPr lang="en-GB" sz="1000" b="1" dirty="0"/>
+              <a:t>ASK</a:t>
+            </a:r>
+          </a:p>
+          <a:p>
+            <a:r>
+              <a:rPr lang="en-GB" sz="1000" dirty="0"/>
+              <a:t>Was anything in that different from what you expected? Most people expect something far more intrusive, and it is worth letting that relief happen.</a:t>
+            </a:r>
           </a:p>
         </p:txBody>
       </p:sp>
@@ -699,13 +921,63 @@
           <a:lstStyle/>
           <a:p>
             <a:r>
-              <a:rPr lang="en-US" dirty="0"/>
-              <a:t>Cue: the word at the screening stage is non-negative, never positive and never a fail.
-Cue: a non-negative screen means the samples go to a laboratory. That is all it means.
-Cue: do not offer any numbers here — the laboratory publishes its own schedule.
-Script booklet, section 8.</a:t>
-            </a:r>
-            <a:endParaRPr lang="en-US" dirty="0"/>
+              <a:rPr lang="en-GB" sz="1000" b="1" dirty="0"/>
+              <a:t>Screening and confirmation · about 3 minutes</a:t>
+            </a:r>
+          </a:p>
+          <a:p>
+            <a:r>
+              <a:rPr lang="en-GB" sz="1000" b="1" dirty="0"/>
+              <a:t>SAY THIS</a:t>
+            </a:r>
+          </a:p>
+          <a:p>
+            <a:r>
+              <a:rPr lang="en-GB" sz="1000" dirty="0"/>
+              <a:t>This next part is the most misunderstood thing about the whole subject, and getting it straight might save somebody here a very bad week.</a:t>
+            </a:r>
+          </a:p>
+          <a:p>
+            <a:r>
+              <a:rPr lang="en-GB" sz="1000" dirty="0"/>
+              <a:t>The device used on site is a screening device. It gives an indication. It does not identify a substance definitively and it is not evidence. That is why we do not use the word positive at that stage. The word is non-negative.</a:t>
+            </a:r>
+          </a:p>
+          <a:p>
+            <a:r>
+              <a:rPr lang="en-GB" sz="1000" dirty="0"/>
+              <a:t>A non-negative screen means one thing: further samples go to a laboratory. Nothing more than that.</a:t>
+            </a:r>
+          </a:p>
+          <a:p>
+            <a:r>
+              <a:rPr lang="en-GB" sz="1000" dirty="0"/>
+              <a:t>Confirmation is a completely different activity, done by a laboratory, using different methods, on separate samples, against that laboratory’s own current published cut-off schedule. That is the evidential step, and that is what produces a certificate.</a:t>
+            </a:r>
+          </a:p>
+          <a:p>
+            <a:r>
+              <a:rPr lang="en-GB" sz="1000" dirty="0"/>
+              <a:t>While that is happening, you are stood down from safety-critical work. That is a precaution, not a punishment and not a finding. A further sample is kept so that independent re-analysis can be asked for if the result is disputed.</a:t>
+            </a:r>
+          </a:p>
+          <a:p>
+            <a:r>
+              <a:rPr lang="en-GB" sz="1000" dirty="0"/>
+              <a:t>So, once more, because it matters: a non-negative screen is not a failed test. It is the point where the sample goes to a laboratory.</a:t>
+            </a:r>
+          </a:p>
+          <a:p>
+            <a:r>
+              <a:rPr lang="en-GB" sz="1000" b="1" dirty="0"/>
+              <a:t>DO</a:t>
+            </a:r>
+          </a:p>
+          <a:p>
+            <a:r>
+              <a:rPr lang="en-GB" sz="1000" dirty="0"/>
+              <a:t>Do not offer any numbers here — not levels, not timings. If you are asked, the honest answer is that the analysing laboratory publishes its own schedule and interprets the result against it. Park anything further.</a:t>
+            </a:r>
           </a:p>
         </p:txBody>
       </p:sp>
@@ -790,13 +1062,63 @@
           <a:lstStyle/>
           <a:p>
             <a:r>
-              <a:rPr lang="en-US" dirty="0"/>
-              <a:t>Cue: declare before a test, not after a result — the order changes everything.
-Cue: nobody has to tell a supervisor what their condition is.
-Cue: on medicinal cannabis and CBD, never say it will not show up. Say it goes to medical review.
-Script booklet, section 9, and the crib sheet.</a:t>
-            </a:r>
-            <a:endParaRPr lang="en-US" dirty="0"/>
+              <a:rPr lang="en-GB" sz="1000" b="1" dirty="0"/>
+              <a:t>Medication · about 3 minutes</a:t>
+            </a:r>
+          </a:p>
+          <a:p>
+            <a:r>
+              <a:rPr lang="en-GB" sz="1000" b="1" dirty="0"/>
+              <a:t>SAY THIS</a:t>
+            </a:r>
+          </a:p>
+          <a:p>
+            <a:r>
+              <a:rPr lang="en-GB" sz="1000" dirty="0"/>
+              <a:t>Three practical points, and for most people in this room these are the most useful three minutes of the talk.</a:t>
+            </a:r>
+          </a:p>
+          <a:p>
+            <a:r>
+              <a:rPr lang="en-GB" sz="1000" dirty="0"/>
+              <a:t>One: both prescribed medicines and things you buy at a pharmacy count. Codeine-containing painkillers, some cough medicines, sedating antihistamines, sleeping tablets, prescribed sedatives. The screening panel does not know why something is there.</a:t>
+            </a:r>
+          </a:p>
+          <a:p>
+            <a:r>
+              <a:rPr lang="en-GB" sz="1000" dirty="0"/>
+              <a:t>Two: declare it before, not after. Before a test, and before your first shift on something new. The confidential route is ⟨Medical declaration route⟩, and you use that rather than telling me what condition you have. You never have to tell your line manager your diagnosis. Declared beforehand, a finding that matches your prescription is explained before anybody could misread it. Declared afterwards, it looks like an excuse produced to fit a result, and that is a much harder road for you.</a:t>
+            </a:r>
+          </a:p>
+          <a:p>
+            <a:r>
+              <a:rPr lang="en-GB" sz="1000" dirty="0"/>
+              <a:t>Three: read the label. If it says may cause drowsiness, or do not drive, or do not operate machinery, that warning is about exactly the work some of you do. Tell somebody so the task can be looked at.</a:t>
+            </a:r>
+          </a:p>
+          <a:p>
+            <a:r>
+              <a:rPr lang="en-GB" sz="1000" dirty="0"/>
+              <a:t>On prescribed cannabis-based products, because it comes up every time: they are medication and they go through the same route. A clinician looks at the laboratory finding alongside your declared prescription. What I am not going to tell you — and what you should not believe from anyone — is that a prescription means nothing will be found. People have got themselves into real difficulty believing that.</a:t>
+            </a:r>
+          </a:p>
+          <a:p>
+            <a:r>
+              <a:rPr lang="en-GB" sz="1000" dirty="0"/>
+              <a:t>And CBD products are not tightly regulated. Some contain more than the label claims. If you use one, declare it the same way.</a:t>
+            </a:r>
+          </a:p>
+          <a:p>
+            <a:r>
+              <a:rPr lang="en-GB" sz="1000" b="1" dirty="0"/>
+              <a:t>ASK</a:t>
+            </a:r>
+          </a:p>
+          <a:p>
+            <a:r>
+              <a:rPr lang="en-GB" sz="1000" dirty="0"/>
+              <a:t>Has anyone here taken something over the counter that carried a drowsiness warning? Antihistamines, cold and flu remedies, strong painkillers — all ordinary, and none of it anybody’s fault.</a:t>
+            </a:r>
           </a:p>
         </p:txBody>
       </p:sp>
@@ -881,13 +1203,45 @@
           <a:lstStyle/>
           <a:p>
             <a:r>
-              <a:rPr lang="en-US" dirty="0"/>
-              <a:t>Cue: results are health data and are handled with stronger protection than ordinary records.
-Cue: a supervisor is told whether someone is fit for work, not what was found.
-Cue: nothing is announced or discussed on the floor.
-Script booklet, section 10.</a:t>
-            </a:r>
-            <a:endParaRPr lang="en-US" dirty="0"/>
+              <a:rPr lang="en-GB" sz="1000" b="1" dirty="0"/>
+              <a:t>Your rights · about 2 minutes</a:t>
+            </a:r>
+          </a:p>
+          <a:p>
+            <a:r>
+              <a:rPr lang="en-GB" sz="1000" b="1" dirty="0"/>
+              <a:t>SAY THIS</a:t>
+            </a:r>
+          </a:p>
+          <a:p>
+            <a:r>
+              <a:rPr lang="en-GB" sz="1000" dirty="0"/>
+              <a:t>Four things you are entitled to, and this is the part people are most anxious about and least often told.</a:t>
+            </a:r>
+          </a:p>
+          <a:p>
+            <a:r>
+              <a:rPr lang="en-GB" sz="1000" dirty="0"/>
+              <a:t>Consent. A sample is given with your agreement, after the procedure has been explained. You can ask for it to be explained again at any point, and you can ask questions throughout.</a:t>
+            </a:r>
+          </a:p>
+          <a:p>
+            <a:r>
+              <a:rPr lang="en-GB" sz="1000" dirty="0"/>
+              <a:t>Dignity. A private room is used — not the canteen, not the shop floor. Nobody stands over you in a way that would embarrass you.</a:t>
+            </a:r>
+          </a:p>
+          <a:p>
+            <a:r>
+              <a:rPr lang="en-GB" sz="1000" dirty="0"/>
+              <a:t>Confidentiality. A result is health information, and it has stronger protection than ordinary records. It goes to the authorised contacts named in the policy and to nobody else. If I am your supervisor, I am told whether you are fit for work. I am not told what was found. Nothing gets announced or discussed on the floor.</a:t>
+            </a:r>
+          </a:p>
+          <a:p>
+            <a:r>
+              <a:rPr lang="en-GB" sz="1000" dirty="0"/>
+              <a:t>And your own information. You can ask what is held about you, ask for a copy, and ask for anything inaccurate to be corrected. Records are kept only for as long as the policy says, and then disposed of securely.</a:t>
+            </a:r>
           </a:p>
         </p:txBody>
       </p:sp>
@@ -972,13 +1326,45 @@
           <a:lstStyle/>
           <a:p>
             <a:r>
-              <a:rPr lang="en-US" dirty="0"/>
-              <a:t>Cue: say this calmly and once. Better known today than discovered on the day.
-Cue: a genuine reason raised at the time is a different thing from a refusal.
-Cue: adulterants and substitutes are detectable, and attempting it is the offence.
-Script booklet, section 11.</a:t>
-            </a:r>
-            <a:endParaRPr lang="en-US" dirty="0"/>
+              <a:rPr lang="en-GB" sz="1000" b="1" dirty="0"/>
+              <a:t>Refusal and tampering · about 2 minutes</a:t>
+            </a:r>
+          </a:p>
+          <a:p>
+            <a:r>
+              <a:rPr lang="en-GB" sz="1000" b="1" dirty="0"/>
+              <a:t>SAY THIS</a:t>
+            </a:r>
+          </a:p>
+          <a:p>
+            <a:r>
+              <a:rPr lang="en-GB" sz="1000" dirty="0"/>
+              <a:t>One short section, said once and calmly, because it is better known today than discovered on the day.</a:t>
+            </a:r>
+          </a:p>
+          <a:p>
+            <a:r>
+              <a:rPr lang="en-GB" sz="1000" dirty="0"/>
+              <a:t>Refusing to give a sample without good reason is generally treated the same as a positive result. So is walking away, so is spinning it out until the collector has to leave, and so is going home when you have been asked to stay.</a:t>
+            </a:r>
+          </a:p>
+          <a:p>
+            <a:r>
+              <a:rPr lang="en-GB" sz="1000" dirty="0"/>
+              <a:t>Substituting a sample, watering it down or adding anything to it is treated as tampering, and it is the attempt that is the issue. The kits and the laboratory checks are designed to show that up.</a:t>
+            </a:r>
+          </a:p>
+          <a:p>
+            <a:r>
+              <a:rPr lang="en-GB" sz="1000" dirty="0"/>
+              <a:t>If there is a genuine reason you cannot provide a sample, say so at the time so it can be written down. That is a completely different thing from a refusal.</a:t>
+            </a:r>
+          </a:p>
+          <a:p>
+            <a:r>
+              <a:rPr lang="en-GB" sz="1000" dirty="0"/>
+              <a:t>Nobody is being asked to prove they are innocent here. The whole process exists so that decisions rest on evidence rather than somebody’s opinion on site.</a:t>
+            </a:r>
           </a:p>
         </p:txBody>
       </p:sp>
@@ -1063,14 +1449,63 @@
           <a:lstStyle/>
           <a:p>
             <a:r>
-              <a:rPr lang="en-US" dirty="0"/>
-              <a:t>Cue: read the routes out slowly and let people photograph the slide.
-Cue: self-referral before selection for testing is treated as a health matter, not a disciplinary one.
-Cue: say that a GP route involves the employer not at all.
-Setup: this is the Northern Ireland version. Delete the other two support slides.
-Script booklet, section 12.</a:t>
-            </a:r>
-            <a:endParaRPr lang="en-US" dirty="0"/>
+              <a:rPr lang="en-GB" sz="1000" b="1" dirty="0"/>
+              <a:t>Support — Northern Ireland version · about 2 minutes</a:t>
+            </a:r>
+          </a:p>
+          <a:p>
+            <a:r>
+              <a:rPr lang="en-GB" sz="1000" dirty="0"/>
+              <a:t>Read these notes only if you kept this version of the slide in the deck.</a:t>
+            </a:r>
+          </a:p>
+          <a:p>
+            <a:r>
+              <a:rPr lang="en-GB" sz="1000" b="1" dirty="0"/>
+              <a:t>SAY THIS</a:t>
+            </a:r>
+          </a:p>
+          <a:p>
+            <a:r>
+              <a:rPr lang="en-GB" sz="1000" dirty="0"/>
+              <a:t>This is the slide to photograph, and I will give you a moment to do it.</a:t>
+            </a:r>
+          </a:p>
+          <a:p>
+            <a:r>
+              <a:rPr lang="en-GB" sz="1000" dirty="0"/>
+              <a:t>If drink or drugs are becoming a problem, say so before it surfaces some other way. Coming forward yourself, before you are ever selected for a test, is treated as a health matter with support — not as a disciplinary matter. Being found out and coming forward are two different things, and the policy knows the difference.</a:t>
+            </a:r>
+          </a:p>
+          <a:p>
+            <a:r>
+              <a:rPr lang="en-GB" sz="1000" dirty="0"/>
+              <a:t>Inside here, the confidential route is ⟨Support contact⟩, and where an employee assistance programme is in place it is free and it does not go through your line manager.</a:t>
+            </a:r>
+          </a:p>
+          <a:p>
+            <a:r>
+              <a:rPr lang="en-GB" sz="1000" dirty="0"/>
+              <a:t>Outside, your GP can treat this as the health matter it is, and that involves your employer not at all. There are also the services listed on nidirect, and the addiction services run by Inspire. Both are open to anybody, at any stage.</a:t>
+            </a:r>
+          </a:p>
+          <a:p>
+            <a:r>
+              <a:rPr lang="en-GB" sz="1000" dirty="0"/>
+              <a:t>Asking for help is not a breach of this policy. Nothing said today should leave anybody thinking the safe move is silence.</a:t>
+            </a:r>
+          </a:p>
+          <a:p>
+            <a:r>
+              <a:rPr lang="en-GB" sz="1000" b="1" dirty="0"/>
+              <a:t>DO</a:t>
+            </a:r>
+          </a:p>
+          <a:p>
+            <a:r>
+              <a:rPr lang="en-GB" sz="1000" dirty="0"/>
+              <a:t>Pause and let people photograph the slide. Then say the last line again.</a:t>
+            </a:r>
           </a:p>
         </p:txBody>
       </p:sp>
@@ -1155,14 +1590,63 @@
           <a:lstStyle/>
           <a:p>
             <a:r>
-              <a:rPr lang="en-US" dirty="0"/>
-              <a:t>Cue: read the routes out slowly and let people photograph the slide.
-Cue: self-referral before selection for testing is treated as a health matter, not a disciplinary one.
-Cue: say that a GP route involves the employer not at all.
-Setup: this is the Republic of Ireland version. Delete the other two support slides.
-Script booklet, section 12.</a:t>
-            </a:r>
-            <a:endParaRPr lang="en-US" dirty="0"/>
+              <a:rPr lang="en-GB" sz="1000" b="1" dirty="0"/>
+              <a:t>Support — Republic of Ireland version · about 2 minutes</a:t>
+            </a:r>
+          </a:p>
+          <a:p>
+            <a:r>
+              <a:rPr lang="en-GB" sz="1000" dirty="0"/>
+              <a:t>Read these notes only if you kept this version of the slide in the deck.</a:t>
+            </a:r>
+          </a:p>
+          <a:p>
+            <a:r>
+              <a:rPr lang="en-GB" sz="1000" b="1" dirty="0"/>
+              <a:t>SAY THIS</a:t>
+            </a:r>
+          </a:p>
+          <a:p>
+            <a:r>
+              <a:rPr lang="en-GB" sz="1000" dirty="0"/>
+              <a:t>This is the slide to photograph, and I will give you a moment to do it.</a:t>
+            </a:r>
+          </a:p>
+          <a:p>
+            <a:r>
+              <a:rPr lang="en-GB" sz="1000" dirty="0"/>
+              <a:t>If drink or drugs are becoming a problem, say so before it surfaces some other way. Coming forward yourself, before you are ever selected for a test, is treated as a health matter with support — not as a disciplinary matter. Being found out and coming forward are two different things, and the policy knows the difference.</a:t>
+            </a:r>
+          </a:p>
+          <a:p>
+            <a:r>
+              <a:rPr lang="en-GB" sz="1000" dirty="0"/>
+              <a:t>Inside here, the confidential route is ⟨Support contact⟩, and where an employee assistance programme is in place it is free and it does not go through your line manager.</a:t>
+            </a:r>
+          </a:p>
+          <a:p>
+            <a:r>
+              <a:rPr lang="en-GB" sz="1000" dirty="0"/>
+              <a:t>Outside, your GP can treat this as the health matter it is, and that involves your employer not at all. There is also the HSE Drugs and Alcohol Helpline, which is open to anybody, at any stage.</a:t>
+            </a:r>
+          </a:p>
+          <a:p>
+            <a:r>
+              <a:rPr lang="en-GB" sz="1000" dirty="0"/>
+              <a:t>Asking for help is not a breach of this policy. Nothing said today should leave anybody thinking the safe move is silence.</a:t>
+            </a:r>
+          </a:p>
+          <a:p>
+            <a:r>
+              <a:rPr lang="en-GB" sz="1000" b="1" dirty="0"/>
+              <a:t>DO</a:t>
+            </a:r>
+          </a:p>
+          <a:p>
+            <a:r>
+              <a:rPr lang="en-GB" sz="1000" dirty="0"/>
+              <a:t>Pause and let people photograph the slide. Then say the last line again.</a:t>
+            </a:r>
           </a:p>
         </p:txBody>
       </p:sp>
@@ -1247,14 +1731,63 @@
           <a:lstStyle/>
           <a:p>
             <a:r>
-              <a:rPr lang="en-US" dirty="0"/>
-              <a:t>Cue: read the routes out slowly and let people photograph the slide.
-Cue: self-referral before selection for testing is treated as a health matter, not a disciplinary one.
-Cue: say that a GP route involves the employer not at all.
-Setup: this is the Great Britain version. Delete the other two support slides.
-Script booklet, section 12.</a:t>
-            </a:r>
-            <a:endParaRPr lang="en-US" dirty="0"/>
+              <a:rPr lang="en-GB" sz="1000" b="1" dirty="0"/>
+              <a:t>Support — Great Britain version · about 2 minutes</a:t>
+            </a:r>
+          </a:p>
+          <a:p>
+            <a:r>
+              <a:rPr lang="en-GB" sz="1000" dirty="0"/>
+              <a:t>Read these notes only if you kept this version of the slide in the deck.</a:t>
+            </a:r>
+          </a:p>
+          <a:p>
+            <a:r>
+              <a:rPr lang="en-GB" sz="1000" b="1" dirty="0"/>
+              <a:t>SAY THIS</a:t>
+            </a:r>
+          </a:p>
+          <a:p>
+            <a:r>
+              <a:rPr lang="en-GB" sz="1000" dirty="0"/>
+              <a:t>This is the slide to photograph, and I will give you a moment to do it.</a:t>
+            </a:r>
+          </a:p>
+          <a:p>
+            <a:r>
+              <a:rPr lang="en-GB" sz="1000" dirty="0"/>
+              <a:t>If drink or drugs are becoming a problem, say so before it surfaces some other way. Coming forward yourself, before you are ever selected for a test, is treated as a health matter with support — not as a disciplinary matter. Being found out and coming forward are two different things, and the policy knows the difference.</a:t>
+            </a:r>
+          </a:p>
+          <a:p>
+            <a:r>
+              <a:rPr lang="en-GB" sz="1000" dirty="0"/>
+              <a:t>Inside here, the confidential route is ⟨Support contact⟩, and where an employee assistance programme is in place it is free and it does not go through your line manager.</a:t>
+            </a:r>
+          </a:p>
+          <a:p>
+            <a:r>
+              <a:rPr lang="en-GB" sz="1000" dirty="0"/>
+              <a:t>Outside, your GP can treat this as the health matter it is, and that involves your employer not at all. There are also the national services — FRANK for drugs and Drinkaware for alcohol. Look up their current contact details before the session so that you can give them out.</a:t>
+            </a:r>
+          </a:p>
+          <a:p>
+            <a:r>
+              <a:rPr lang="en-GB" sz="1000" dirty="0"/>
+              <a:t>Asking for help is not a breach of this policy. Nothing said today should leave anybody thinking the safe move is silence.</a:t>
+            </a:r>
+          </a:p>
+          <a:p>
+            <a:r>
+              <a:rPr lang="en-GB" sz="1000" b="1" dirty="0"/>
+              <a:t>DO</a:t>
+            </a:r>
+          </a:p>
+          <a:p>
+            <a:r>
+              <a:rPr lang="en-GB" sz="1000" dirty="0"/>
+              <a:t>Pause and let people photograph the slide. Then say the last line again.</a:t>
+            </a:r>
           </a:p>
         </p:txBody>
       </p:sp>
@@ -1339,14 +1872,201 @@
           <a:lstStyle/>
           <a:p>
             <a:r>
-              <a:rPr lang="en-US" dirty="0"/>
-              <a:t>Answers, for the presenter.
-1. What single question is the policy asking? Whether you are fit to do your work safely today.
-2. What does a non-negative screen mean? That the sample goes to a laboratory for confirmation. It is not a positive and it is not a fail.
-3. When do you declare medication? Before a test, and before your first shift on anything new that carries a drowsiness or machinery warning. You never have to state the diagnosis.
-If anyone asks something you cannot answer, park it on the sign-off sheet and pass it to ⟨Policy owner⟩ after the talk.</a:t>
-            </a:r>
-            <a:endParaRPr lang="en-US" dirty="0"/>
+              <a:rPr lang="en-GB" sz="1000" b="1" dirty="0"/>
+              <a:t>Knowledge check · about 2 minutes</a:t>
+            </a:r>
+          </a:p>
+          <a:p>
+            <a:r>
+              <a:rPr lang="en-GB" sz="1000" b="1" dirty="0"/>
+              <a:t>SAY THIS</a:t>
+            </a:r>
+          </a:p>
+          <a:p>
+            <a:r>
+              <a:rPr lang="en-GB" sz="1000" dirty="0"/>
+              <a:t>Three quick questions before we finish. Hands up, nothing is written down and nothing is scored.</a:t>
+            </a:r>
+          </a:p>
+          <a:p>
+            <a:r>
+              <a:rPr lang="en-GB" sz="1000" dirty="0"/>
+              <a:t>One. What single question is the policy asking of you?</a:t>
+            </a:r>
+          </a:p>
+          <a:p>
+            <a:r>
+              <a:rPr lang="en-GB" sz="1000" dirty="0"/>
+              <a:t>— Whether you are fit to do your work safely today.</a:t>
+            </a:r>
+          </a:p>
+          <a:p>
+            <a:r>
+              <a:rPr lang="en-GB" sz="1000" dirty="0"/>
+              <a:t>Two. What does a non-negative screening result mean?</a:t>
+            </a:r>
+          </a:p>
+          <a:p>
+            <a:r>
+              <a:rPr lang="en-GB" sz="1000" dirty="0"/>
+              <a:t>— That the sample goes to a laboratory for confirmation. It is not a positive and it is not a fail.</a:t>
+            </a:r>
+          </a:p>
+          <a:p>
+            <a:r>
+              <a:rPr lang="en-GB" sz="1000" dirty="0"/>
+              <a:t>Three. When do you declare medication, and what do you not have to say?</a:t>
+            </a:r>
+          </a:p>
+          <a:p>
+            <a:r>
+              <a:rPr lang="en-GB" sz="1000" dirty="0"/>
+              <a:t>— Before a test, and before your first shift on anything new that carries a drowsiness or machinery warning. You never have to say what the condition is.</a:t>
+            </a:r>
+          </a:p>
+          <a:p>
+            <a:r>
+              <a:rPr lang="en-GB" sz="1000" b="1" dirty="0"/>
+              <a:t>DO</a:t>
+            </a:r>
+          </a:p>
+          <a:p>
+            <a:r>
+              <a:rPr lang="en-GB" sz="1000" dirty="0"/>
+              <a:t>Give the answer straight after each question rather than letting the room guess for long.</a:t>
+            </a:r>
+          </a:p>
+          <a:p>
+            <a:r>
+              <a:rPr lang="en-GB" sz="1000" b="1" dirty="0"/>
+              <a:t>Crib sheet — the five questions you will be asked</a:t>
+            </a:r>
+          </a:p>
+          <a:p>
+            <a:r>
+              <a:rPr lang="en-GB" sz="1000" dirty="0"/>
+              <a:t>These five come up in almost every session. Safe answers are below. Anything that goes further belongs on the sign-off sheet, not in an answer you invent.</a:t>
+            </a:r>
+          </a:p>
+          <a:p>
+            <a:r>
+              <a:rPr lang="en-GB" sz="1000" b="1" dirty="0"/>
+              <a:t>1.  “I have a prescription for medicinal cannabis. Where does that leave me?”</a:t>
+            </a:r>
+          </a:p>
+          <a:p>
+            <a:r>
+              <a:rPr lang="en-GB" sz="1000" b="1" dirty="0"/>
+              <a:t>SAY THIS</a:t>
+            </a:r>
+          </a:p>
+          <a:p>
+            <a:r>
+              <a:rPr lang="en-GB" sz="1000" dirty="0"/>
+              <a:t>It is medication, and it goes through the same route as any other prescription: declared confidentially in advance, then assessed through medical review, where a clinician looks at the laboratory finding alongside your declared prescription. Declared and reviewed properly, that is not a policy breach.</a:t>
+            </a:r>
+          </a:p>
+          <a:p>
+            <a:r>
+              <a:rPr lang="en-GB" sz="1000" dirty="0"/>
+              <a:t>Keep in mind: Never say a prescription means it will not show up. That is wrong and people have got into real difficulty believing it. Separately, the safety question stands on its own — if a medicine affects attention or coordination, the task may need to change.</a:t>
+            </a:r>
+          </a:p>
+          <a:p>
+            <a:r>
+              <a:rPr lang="en-GB" sz="1000" b="1" dirty="0"/>
+              <a:t>2.  “What about CBD? That is legal, isn’t it.”</a:t>
+            </a:r>
+          </a:p>
+          <a:p>
+            <a:r>
+              <a:rPr lang="en-GB" sz="1000" b="1" dirty="0"/>
+              <a:t>SAY THIS</a:t>
+            </a:r>
+          </a:p>
+          <a:p>
+            <a:r>
+              <a:rPr lang="en-GB" sz="1000" dirty="0"/>
+              <a:t>CBD products are not tightly regulated, and some have been found to contain more than the label claims, including THC. That is why you declare it through the same confidential route.</a:t>
+            </a:r>
+          </a:p>
+          <a:p>
+            <a:r>
+              <a:rPr lang="en-GB" sz="1000" dirty="0"/>
+              <a:t>Keep in mind: Do not get drawn into what is or is not legal to buy. The point for us is the declaration, not the shop.</a:t>
+            </a:r>
+          </a:p>
+          <a:p>
+            <a:r>
+              <a:rPr lang="en-GB" sz="1000" b="1" dirty="0"/>
+              <a:t>3.  “I am on prescribed medication. Am I in trouble?”</a:t>
+            </a:r>
+          </a:p>
+          <a:p>
+            <a:r>
+              <a:rPr lang="en-GB" sz="1000" b="1" dirty="0"/>
+              <a:t>SAY THIS</a:t>
+            </a:r>
+          </a:p>
+          <a:p>
+            <a:r>
+              <a:rPr lang="en-GB" sz="1000" dirty="0"/>
+              <a:t>No. A declared, prescribed medicine handled through medical review is not a disciplinary matter. You declare it confidentially, you do not have to tell your line manager the condition, and the clinical detail goes to the reviewing clinician rather than to management.</a:t>
+            </a:r>
+          </a:p>
+          <a:p>
+            <a:r>
+              <a:rPr lang="en-GB" sz="1000" dirty="0"/>
+              <a:t>Keep in mind: The one thing that matters is the order: declared before, not explained after.</a:t>
+            </a:r>
+          </a:p>
+          <a:p>
+            <a:r>
+              <a:rPr lang="en-GB" sz="1000" b="1" dirty="0"/>
+              <a:t>4.  “How long does it stay in your system?”</a:t>
+            </a:r>
+          </a:p>
+          <a:p>
+            <a:r>
+              <a:rPr lang="en-GB" sz="1000" b="1" dirty="0"/>
+              <a:t>SAY THIS</a:t>
+            </a:r>
+          </a:p>
+          <a:p>
+            <a:r>
+              <a:rPr lang="en-GB" sz="1000" dirty="0"/>
+              <a:t>It varies — by substance, by the person, and by how much and how often. That is why nobody sensible gives a figure. A result is interpreted by the analysing laboratory against its own current published cut-off schedule, and it is the laboratory that does the interpreting.</a:t>
+            </a:r>
+          </a:p>
+          <a:p>
+            <a:r>
+              <a:rPr lang="en-GB" sz="1000" dirty="0"/>
+              <a:t>Keep in mind: Give no figures of any kind here. If they push, park it on the sheet.</a:t>
+            </a:r>
+          </a:p>
+          <a:p>
+            <a:r>
+              <a:rPr lang="en-GB" sz="1000" b="1" dirty="0"/>
+              <a:t>5.  “What if I was drinking the night before?”</a:t>
+            </a:r>
+          </a:p>
+          <a:p>
+            <a:r>
+              <a:rPr lang="en-GB" sz="1000" b="1" dirty="0"/>
+              <a:t>SAY THIS</a:t>
+            </a:r>
+          </a:p>
+          <a:p>
+            <a:r>
+              <a:rPr lang="en-GB" sz="1000" dirty="0"/>
+              <a:t>Alcohol can still be present the next morning, and people routinely underestimate that. If you are in any doubt about whether you are fit, do not drive and do not start — say so instead. Nobody is disciplined for saying they are not fit before a shift begins.</a:t>
+            </a:r>
+          </a:p>
+          <a:p>
+            <a:r>
+              <a:rPr lang="en-GB" sz="1000" dirty="0"/>
+              <a:t>Keep in mind: No maths, no rules of thumb, no figures. The answer is the doubt test, not a calculation.</a:t>
+            </a:r>
           </a:p>
         </p:txBody>
       </p:sp>
@@ -1431,13 +2151,135 @@
           <a:lstStyle/>
           <a:p>
             <a:r>
-              <a:rPr lang="en-US" dirty="0"/>
-              <a:t>Cue: give the three things to remember, then the closing sentence.
-Cue: pass the sign-off sheet round — print, sign, date.
-Cue: write any parked question on the sheet and pass it to ⟨Policy owner⟩ afterwards. Never guess an answer.
-Script booklet, section 14 and the back page.</a:t>
-            </a:r>
-            <a:endParaRPr lang="en-US" dirty="0"/>
+              <a:rPr lang="en-GB" sz="1000" b="1" dirty="0"/>
+              <a:t>Close · about 2 minutes</a:t>
+            </a:r>
+          </a:p>
+          <a:p>
+            <a:r>
+              <a:rPr lang="en-GB" sz="1000" b="1" dirty="0"/>
+              <a:t>SAY THIS</a:t>
+            </a:r>
+          </a:p>
+          <a:p>
+            <a:r>
+              <a:rPr lang="en-GB" sz="1000" dirty="0"/>
+              <a:t>If you forget everything else, keep three things.</a:t>
+            </a:r>
+          </a:p>
+          <a:p>
+            <a:r>
+              <a:rPr lang="en-GB" sz="1000" dirty="0"/>
+              <a:t>One: the policy asks one question, and it is about today, not about your private life.</a:t>
+            </a:r>
+          </a:p>
+          <a:p>
+            <a:r>
+              <a:rPr lang="en-GB" sz="1000" dirty="0"/>
+              <a:t>Two: a screening device indicates, a laboratory confirms, and a clinician reviews declared medication. Nothing about you gets decided on one device in a room.</a:t>
+            </a:r>
+          </a:p>
+          <a:p>
+            <a:r>
+              <a:rPr lang="en-GB" sz="1000" dirty="0"/>
+              <a:t>Three: declare your medication and ask for help early. Both of those are ordinary things to do.</a:t>
+            </a:r>
+          </a:p>
+          <a:p>
+            <a:r>
+              <a:rPr lang="en-GB" sz="1000" dirty="0"/>
+              <a:t>And the sentence this whole talk exists for: everyone who comes to work healthy and well goes home the same way. That is the standard, and it applies to every person here, including me.</a:t>
+            </a:r>
+          </a:p>
+          <a:p>
+            <a:r>
+              <a:rPr lang="en-GB" sz="1000" dirty="0"/>
+              <a:t>The sign-off sheet is going round now. Print your name, sign it, date it. It records that the policy was talked through with you, nothing more. If you asked something I could not answer, it is written on that sheet and it goes to ⟨Policy owner⟩, who will come back to you.</a:t>
+            </a:r>
+          </a:p>
+          <a:p>
+            <a:r>
+              <a:rPr lang="en-GB" sz="1000" b="1" dirty="0"/>
+              <a:t>DO</a:t>
+            </a:r>
+          </a:p>
+          <a:p>
+            <a:r>
+              <a:rPr lang="en-GB" sz="1000" dirty="0"/>
+              <a:t>Pass the sheet round and stay behind for a few minutes for anyone who wants a private word.</a:t>
+            </a:r>
+          </a:p>
+          <a:p>
+            <a:r>
+              <a:rPr lang="en-GB" sz="1000" b="1" dirty="0"/>
+              <a:t>After the talk</a:t>
+            </a:r>
+          </a:p>
+          <a:p>
+            <a:r>
+              <a:rPr lang="en-GB" sz="1000" dirty="0"/>
+              <a:t>Four things, and then you are finished.</a:t>
+            </a:r>
+          </a:p>
+          <a:p>
+            <a:r>
+              <a:rPr lang="en-GB" sz="1000" dirty="0"/>
+              <a:t>Check the sign-off sheet is complete. Every person present should have printed their name and signed, including you. Fill in the site, the date and the policy version at the top.</a:t>
+            </a:r>
+          </a:p>
+          <a:p>
+            <a:r>
+              <a:rPr lang="en-GB" sz="1000" dirty="0"/>
+              <a:t>File it. The completed sheet goes to ⟨Policy owner⟩ and is kept as the record that the policy was communicated. It records attendance, not a score.</a:t>
+            </a:r>
+          </a:p>
+          <a:p>
+            <a:r>
+              <a:rPr lang="en-GB" sz="1000" dirty="0"/>
+              <a:t>Pass on the parked questions. Anything written in the parked questions box goes to ⟨Policy owner⟩ with the sheet. They resolve each one against the policy, or through the organisation’s testing provider arrangements, and the answer goes back to whoever asked — by email to the team, or at the next briefing.</a:t>
+            </a:r>
+          </a:p>
+          <a:p>
+            <a:r>
+              <a:rPr lang="en-GB" sz="1000" dirty="0"/>
+              <a:t>Follow anything up quietly. If somebody asked for a private word, or asked for the support contact, deal with that the same day and keep it to yourself.</a:t>
+            </a:r>
+          </a:p>
+          <a:p>
+            <a:r>
+              <a:rPr lang="en-GB" sz="1000" b="1" dirty="0"/>
+              <a:t>Repeating the talk</a:t>
+            </a:r>
+          </a:p>
+          <a:p>
+            <a:r>
+              <a:rPr lang="en-GB" sz="1000" dirty="0"/>
+              <a:t>Run it again for anyone who was not there — nights, holidays, long-term absence — and for new starters as part of induction.</a:t>
+            </a:r>
+          </a:p>
+          <a:p>
+            <a:r>
+              <a:rPr lang="en-GB" sz="1000" dirty="0"/>
+              <a:t>Refresh it periodically, and always when the policy changes. Record the new policy version on the new sheet.</a:t>
+            </a:r>
+          </a:p>
+          <a:p>
+            <a:r>
+              <a:rPr lang="en-GB" sz="1000" dirty="0"/>
+              <a:t>If your policy or your testing arrangements change, ask ⟨Policy owner⟩ for the updated deck before running it again.</a:t>
+            </a:r>
+          </a:p>
+          <a:p>
+            <a:r>
+              <a:rPr lang="en-GB" sz="1000" b="1" dirty="0"/>
+              <a:t>Where questions go</a:t>
+            </a:r>
+          </a:p>
+          <a:p>
+            <a:r>
+              <a:rPr lang="en-GB" sz="1000" dirty="0"/>
+              <a:t>Questions raised in the session go to ⟨Policy owner⟩, who resolves them against the policy or through the organisation’s testing provider arrangements. Problems with the pack files themselves: NIVHA Laboratory Services · info@nivha.net · 02890 737942.</a:t>
+            </a:r>
           </a:p>
         </p:txBody>
       </p:sp>
@@ -1522,13 +2364,51 @@
           <a:lstStyle/>
           <a:p>
             <a:r>
-              <a:rPr lang="en-US" dirty="0"/>
-              <a:t>Cue: welcome everyone, say who you are and that this is a short safety briefing.
-Cue: two promises — nobody is in trouble, and you will show how a test actually works.
-Cue: say the session takes about half an hour and there is a sheet to sign at the end.
-Full words for this slide are in the delivery script booklet, section 1.</a:t>
-            </a:r>
-            <a:endParaRPr lang="en-US" dirty="0"/>
+              <a:rPr lang="en-GB" sz="1000" b="1" dirty="0"/>
+              <a:t>Cover — welcome · about 1 minute</a:t>
+            </a:r>
+          </a:p>
+          <a:p>
+            <a:r>
+              <a:rPr lang="en-GB" sz="1000" dirty="0"/>
+              <a:t>Words in ⟨angle brackets⟩ are filled in from your policy before the talk. Read the SAY THIS text aloud, or put it in your own words if that lands better. The DO and ASK prompts are for you, not the room.</a:t>
+            </a:r>
+          </a:p>
+          <a:p>
+            <a:r>
+              <a:rPr lang="en-GB" sz="1000" b="1" dirty="0"/>
+              <a:t>SAY THIS</a:t>
+            </a:r>
+          </a:p>
+          <a:p>
+            <a:r>
+              <a:rPr lang="en-GB" sz="1000" dirty="0"/>
+              <a:t>Morning, everyone. Thanks for stopping. This is a short toolbox talk about drugs and alcohol at work, and it will take about half an hour.</a:t>
+            </a:r>
+          </a:p>
+          <a:p>
+            <a:r>
+              <a:rPr lang="en-GB" sz="1000" dirty="0"/>
+              <a:t>Before we start, two things. First, nobody is in trouble and this is not an investigation — it is a briefing, the same as any other safety briefing we do. Second, I am going to show you exactly how a test works, step by step, so that if you are ever asked to do one, you already know what happens.</a:t>
+            </a:r>
+          </a:p>
+          <a:p>
+            <a:r>
+              <a:rPr lang="en-GB" sz="1000" dirty="0"/>
+              <a:t>I did not write this and I am not an expert on it. It was put together with NIVHA Laboratory Services, who do the testing. If you ask me something I do not know, I will write it down and get you a proper answer afterwards rather than make one up.</a:t>
+            </a:r>
+          </a:p>
+          <a:p>
+            <a:r>
+              <a:rPr lang="en-GB" sz="1000" b="1" dirty="0"/>
+              <a:t>DO</a:t>
+            </a:r>
+          </a:p>
+          <a:p>
+            <a:r>
+              <a:rPr lang="en-GB" sz="1000" dirty="0"/>
+              <a:t>Have the sign-off sheet out where people can see it. Say it goes round at the end.</a:t>
+            </a:r>
           </a:p>
         </p:txBody>
       </p:sp>
@@ -1613,13 +2493,51 @@
           <a:lstStyle/>
           <a:p>
             <a:r>
-              <a:rPr lang="en-US" dirty="0"/>
-              <a:t>Cue: this is not about anyone's weekend or private life.
-Cue: the one question is whether a person is fit to work safely today.
-Cue: mention that there is a support route, and you will come back to it.
-Script booklet, section 2.</a:t>
-            </a:r>
-            <a:endParaRPr lang="en-US" dirty="0"/>
+              <a:rPr lang="en-GB" sz="1000" b="1" dirty="0"/>
+              <a:t>Why we are talking about this · about 2 minutes</a:t>
+            </a:r>
+          </a:p>
+          <a:p>
+            <a:r>
+              <a:rPr lang="en-GB" sz="1000" b="1" dirty="0"/>
+              <a:t>SAY THIS</a:t>
+            </a:r>
+          </a:p>
+          <a:p>
+            <a:r>
+              <a:rPr lang="en-GB" sz="1000" dirty="0"/>
+              <a:t>Here is what this is not. It is not about your weekend. It is not about your private life or what anybody does on their own time. Nobody is policing that and nobody wants to.</a:t>
+            </a:r>
+          </a:p>
+          <a:p>
+            <a:r>
+              <a:rPr lang="en-GB" sz="1000" dirty="0"/>
+              <a:t>The policy asks one question, and it is a narrow one: are you fit to do your work safely today? If the answer is yes, the policy never touches you. If the answer is no, the policy is the thing that stops you getting hurt.</a:t>
+            </a:r>
+          </a:p>
+          <a:p>
+            <a:r>
+              <a:rPr lang="en-GB" sz="1000" dirty="0"/>
+              <a:t>There is a duty on both sides here. The company has to protect everyone at work, so far as is reasonably practicable. And each of us has a duty not to be under the influence of anything to the point where we put ourselves or somebody else in danger.</a:t>
+            </a:r>
+          </a:p>
+          <a:p>
+            <a:r>
+              <a:rPr lang="en-GB" sz="1000" dirty="0"/>
+              <a:t>The other half of it is support, and I will come back to that near the end. Almost everybody who ends up in trouble over drink or drugs at work knew there was a problem beforehand and said nothing. There is a door in this policy for that moment.</a:t>
+            </a:r>
+          </a:p>
+          <a:p>
+            <a:r>
+              <a:rPr lang="en-GB" sz="1000" b="1" dirty="0"/>
+              <a:t>ASK</a:t>
+            </a:r>
+          </a:p>
+          <a:p>
+            <a:r>
+              <a:rPr lang="en-GB" sz="1000" dirty="0"/>
+              <a:t>Which three jobs on this site would go worst wrong if someone lost concentration for a second? Take a few answers and keep them in mind — you will refer back.</a:t>
+            </a:r>
           </a:p>
         </p:txBody>
       </p:sp>
@@ -1704,14 +2622,63 @@
           <a:lstStyle/>
           <a:p>
             <a:r>
-              <a:rPr lang="en-US" dirty="0"/>
-              <a:t>Cue: read the numbers out, let them land, do not dwell.
-Cue: these come from the statistics agencies, not from campaign groups.
-Cue: point out that in any large workforce some people will be affected.
-Setup: this is the Northern Ireland version. Delete the other two scale slides.
-Script booklet, section 3.</a:t>
-            </a:r>
-            <a:endParaRPr lang="en-US" dirty="0"/>
+              <a:rPr lang="en-GB" sz="1000" b="1" dirty="0"/>
+              <a:t>The scale of it — Northern Ireland version · about 2 minutes</a:t>
+            </a:r>
+          </a:p>
+          <a:p>
+            <a:r>
+              <a:rPr lang="en-GB" sz="1000" dirty="0"/>
+              <a:t>Read these notes only if you kept this version of the slide in the deck.</a:t>
+            </a:r>
+          </a:p>
+          <a:p>
+            <a:r>
+              <a:rPr lang="en-GB" sz="1000" b="1" dirty="0"/>
+              <a:t>SAY THIS</a:t>
+            </a:r>
+          </a:p>
+          <a:p>
+            <a:r>
+              <a:rPr lang="en-GB" sz="1000" dirty="0"/>
+              <a:t>I want to give you some numbers, because most people think this is somebody else’s problem, somewhere else.</a:t>
+            </a:r>
+          </a:p>
+          <a:p>
+            <a:r>
+              <a:rPr lang="en-GB" sz="1000" dirty="0"/>
+              <a:t>In Northern Ireland, two hundred and fifty-one drug-related deaths were registered in 2024, and the great majority of those met the definition of drug misuse.</a:t>
+            </a:r>
+          </a:p>
+          <a:p>
+            <a:r>
+              <a:rPr lang="en-GB" sz="1000" dirty="0"/>
+              <a:t>The single drug named most often was pregabalin, which is a prescription medicine, on just over a hundred of those certificates. That one is worth pausing on, because it breaks the assumption that this is only about something bought on a street corner.</a:t>
+            </a:r>
+          </a:p>
+          <a:p>
+            <a:r>
+              <a:rPr lang="en-GB" sz="1000" dirty="0"/>
+              <a:t>Opioids as a group appeared most often overall, and the highest rate was in the thirty-five to forty-four age group.</a:t>
+            </a:r>
+          </a:p>
+          <a:p>
+            <a:r>
+              <a:rPr lang="en-GB" sz="1000" dirty="0"/>
+              <a:t>These are not figures from a campaign group. They are from the statistics agency. And these are working-age people — people with jobs, in workplaces like this one.</a:t>
+            </a:r>
+          </a:p>
+          <a:p>
+            <a:r>
+              <a:rPr lang="en-GB" sz="1000" b="1" dirty="0"/>
+              <a:t>DO</a:t>
+            </a:r>
+          </a:p>
+          <a:p>
+            <a:r>
+              <a:rPr lang="en-GB" sz="1000" dirty="0"/>
+              <a:t>Read the numbers, let them land, and move on. Do not dwell. Somebody in the room may have lost a person this way.</a:t>
+            </a:r>
           </a:p>
         </p:txBody>
       </p:sp>
@@ -1796,14 +2763,57 @@
           <a:lstStyle/>
           <a:p>
             <a:r>
-              <a:rPr lang="en-US" dirty="0"/>
-              <a:t>Cue: read the numbers out, let them land, do not dwell.
-Cue: these come from the statistics agencies, not from campaign groups.
-Cue: point out that in any large workforce some people will be affected.
-Setup: this is the Republic of Ireland version. Delete the other two scale slides.
-Script booklet, section 3.</a:t>
-            </a:r>
-            <a:endParaRPr lang="en-US" dirty="0"/>
+              <a:rPr lang="en-GB" sz="1000" b="1" dirty="0"/>
+              <a:t>The scale of it — Republic of Ireland version · about 2 minutes</a:t>
+            </a:r>
+          </a:p>
+          <a:p>
+            <a:r>
+              <a:rPr lang="en-GB" sz="1000" dirty="0"/>
+              <a:t>Read these notes only if you kept this version of the slide in the deck.</a:t>
+            </a:r>
+          </a:p>
+          <a:p>
+            <a:r>
+              <a:rPr lang="en-GB" sz="1000" b="1" dirty="0"/>
+              <a:t>SAY THIS</a:t>
+            </a:r>
+          </a:p>
+          <a:p>
+            <a:r>
+              <a:rPr lang="en-GB" sz="1000" dirty="0"/>
+              <a:t>I want to give you some numbers, because most people think this is somebody else’s problem, somewhere else.</a:t>
+            </a:r>
+          </a:p>
+          <a:p>
+            <a:r>
+              <a:rPr lang="en-GB" sz="1000" dirty="0"/>
+              <a:t>In Ireland, three hundred and forty-three drug poisoning deaths were recorded in 2022, which was the second year running that the figure fell.</a:t>
+            </a:r>
+          </a:p>
+          <a:p>
+            <a:r>
+              <a:rPr lang="en-GB" sz="1000" dirty="0"/>
+              <a:t>Cocaine was implicated in about a third of them. And cocaine poisoning deaths rose by two hundred and fifty-nine per cent between 2013 and 2022, the largest rise of any drug group.</a:t>
+            </a:r>
+          </a:p>
+          <a:p>
+            <a:r>
+              <a:rPr lang="en-GB" sz="1000" dirty="0"/>
+              <a:t>These are not figures from a campaign group. They come from the Health Research Board, which examines every case rather than sampling. And these are working-age people — people with jobs, in workplaces like this one.</a:t>
+            </a:r>
+          </a:p>
+          <a:p>
+            <a:r>
+              <a:rPr lang="en-GB" sz="1000" b="1" dirty="0"/>
+              <a:t>DO</a:t>
+            </a:r>
+          </a:p>
+          <a:p>
+            <a:r>
+              <a:rPr lang="en-GB" sz="1000" dirty="0"/>
+              <a:t>Read the numbers, let them land, and move on. Do not dwell. Somebody in the room may have lost a person this way.</a:t>
+            </a:r>
           </a:p>
         </p:txBody>
       </p:sp>
@@ -1888,14 +2898,57 @@
           <a:lstStyle/>
           <a:p>
             <a:r>
-              <a:rPr lang="en-US" dirty="0"/>
-              <a:t>Cue: read the numbers out, let them land, do not dwell.
-Cue: these come from the statistics agencies, not from campaign groups.
-Cue: point out that in any large workforce some people will be affected.
-Setup: this is the Great Britain version. Delete the other two scale slides.
-Script booklet, section 3.</a:t>
-            </a:r>
-            <a:endParaRPr lang="en-US" dirty="0"/>
+              <a:rPr lang="en-GB" sz="1000" b="1" dirty="0"/>
+              <a:t>The scale of it — Great Britain version · about 2 minutes</a:t>
+            </a:r>
+          </a:p>
+          <a:p>
+            <a:r>
+              <a:rPr lang="en-GB" sz="1000" dirty="0"/>
+              <a:t>Read these notes only if you kept this version of the slide in the deck.</a:t>
+            </a:r>
+          </a:p>
+          <a:p>
+            <a:r>
+              <a:rPr lang="en-GB" sz="1000" b="1" dirty="0"/>
+              <a:t>SAY THIS</a:t>
+            </a:r>
+          </a:p>
+          <a:p>
+            <a:r>
+              <a:rPr lang="en-GB" sz="1000" dirty="0"/>
+              <a:t>I want to give you some numbers, because most people think this is somebody else’s problem, somewhere else.</a:t>
+            </a:r>
+          </a:p>
+          <a:p>
+            <a:r>
+              <a:rPr lang="en-GB" sz="1000" dirty="0"/>
+              <a:t>In England and Wales, five and a half thousand deaths related to drug poisoning were registered in 2024. That is the highest number since these figures began in 1993.</a:t>
+            </a:r>
+          </a:p>
+          <a:p>
+            <a:r>
+              <a:rPr lang="en-GB" sz="1000" dirty="0"/>
+              <a:t>Getting on for thirteen hundred of those involved cocaine, and that was a rise of more than fourteen per cent in a single year. The rate has gone up every year since 2012.</a:t>
+            </a:r>
+          </a:p>
+          <a:p>
+            <a:r>
+              <a:rPr lang="en-GB" sz="1000" dirty="0"/>
+              <a:t>These are not figures from a campaign group. They are from the statistics agency. And these are working-age people — people with jobs, in workplaces like this one.</a:t>
+            </a:r>
+          </a:p>
+          <a:p>
+            <a:r>
+              <a:rPr lang="en-GB" sz="1000" b="1" dirty="0"/>
+              <a:t>DO</a:t>
+            </a:r>
+          </a:p>
+          <a:p>
+            <a:r>
+              <a:rPr lang="en-GB" sz="1000" dirty="0"/>
+              <a:t>Read the numbers, let them land, and move on. Do not dwell. Somebody in the room may have lost a person this way.</a:t>
+            </a:r>
           </a:p>
         </p:txBody>
       </p:sp>
@@ -1980,13 +3033,51 @@
           <a:lstStyle/>
           <a:p>
             <a:r>
-              <a:rPr lang="en-US" dirty="0"/>
-              <a:t>Cue: run through the four groups, pausing on medication.
-Cue: the screening panel does not know why something is in a sample — declaring supplies the why.
-Cue: ask nobody to name names or personal examples.
-Script booklet, section 4.</a:t>
-            </a:r>
-            <a:endParaRPr lang="en-US" dirty="0"/>
+              <a:rPr lang="en-GB" sz="1000" b="1" dirty="0"/>
+              <a:t>What counts · about 2 minutes</a:t>
+            </a:r>
+          </a:p>
+          <a:p>
+            <a:r>
+              <a:rPr lang="en-GB" sz="1000" b="1" dirty="0"/>
+              <a:t>SAY THIS</a:t>
+            </a:r>
+          </a:p>
+          <a:p>
+            <a:r>
+              <a:rPr lang="en-GB" sz="1000" dirty="0"/>
+              <a:t>When the policy says drugs and alcohol, it means four things, and the last two catch people out.</a:t>
+            </a:r>
+          </a:p>
+          <a:p>
+            <a:r>
+              <a:rPr lang="en-GB" sz="1000" dirty="0"/>
+              <a:t>Alcohol — during working hours and paid breaks, and bear in mind it can still be affecting you the morning after a heavy night.</a:t>
+            </a:r>
+          </a:p>
+          <a:p>
+            <a:r>
+              <a:rPr lang="en-GB" sz="1000" dirty="0"/>
+              <a:t>Illegal drugs — cocaine is the one found most often in workplace samples now, with cannabis second.</a:t>
+            </a:r>
+          </a:p>
+          <a:p>
+            <a:r>
+              <a:rPr lang="en-GB" sz="1000" dirty="0"/>
+              <a:t>Prescription and pharmacy medicines — only where they are misused, or where something that affects your alertness has not been declared. Strong painkillers, some cough medicines, sedating antihistamines, sleeping tablets. The test does not know why something is in your system. Declaring is what supplies the why.</a:t>
+            </a:r>
+          </a:p>
+          <a:p>
+            <a:r>
+              <a:rPr lang="en-GB" sz="1000" dirty="0"/>
+              <a:t>And psychoactive substances — the things sold as legal highs. Nobody taking them knows what is actually in them, which is exactly the problem.</a:t>
+            </a:r>
+          </a:p>
+          <a:p>
+            <a:r>
+              <a:rPr lang="en-GB" sz="1000" dirty="0"/>
+              <a:t>To be clear: a prescribed medicine that you have declared, handled properly, is not a breach of the policy. An undeclared one is a different conversation.</a:t>
+            </a:r>
           </a:p>
         </p:txBody>
       </p:sp>
@@ -2071,13 +3162,63 @@
           <a:lstStyle/>
           <a:p>
             <a:r>
-              <a:rPr lang="en-US" dirty="0"/>
-              <a:t>Cue: link each effect to a real task on this site — driving, lifting, working at height.
-Cue: the person affected is usually the last to notice.
-Cue: ask the room which tasks here would be worst hit by a lapse of attention.
-Script booklet, section 5.</a:t>
-            </a:r>
-            <a:endParaRPr lang="en-US" dirty="0"/>
+              <a:rPr lang="en-GB" sz="1000" b="1" dirty="0"/>
+              <a:t>Effects at work · about 2 minutes</a:t>
+            </a:r>
+          </a:p>
+          <a:p>
+            <a:r>
+              <a:rPr lang="en-GB" sz="1000" b="1" dirty="0"/>
+              <a:t>SAY THIS</a:t>
+            </a:r>
+          </a:p>
+          <a:p>
+            <a:r>
+              <a:rPr lang="en-GB" sz="1000" dirty="0"/>
+              <a:t>You do not need any science for this part. There are four things that go, and every one of them matters on this site.</a:t>
+            </a:r>
+          </a:p>
+          <a:p>
+            <a:r>
+              <a:rPr lang="en-GB" sz="1000" dirty="0"/>
+              <a:t>Judgement goes first. Risks look smaller than they are and shortcuts start to feel reasonable.</a:t>
+            </a:r>
+          </a:p>
+          <a:p>
+            <a:r>
+              <a:rPr lang="en-GB" sz="1000" dirty="0"/>
+              <a:t>Reaction time stretches — the gap between seeing something and doing something about it. Around moving plant, that gap is the whole margin of safety.</a:t>
+            </a:r>
+          </a:p>
+          <a:p>
+            <a:r>
+              <a:rPr lang="en-GB" sz="1000" dirty="0"/>
+              <a:t>Coordination and balance slip. Grip, footing, fine control. That shows up fast on a ladder or with a tool in your hand.</a:t>
+            </a:r>
+          </a:p>
+          <a:p>
+            <a:r>
+              <a:rPr lang="en-GB" sz="1000" dirty="0"/>
+              <a:t>And attention drifts, with tiredness that can last well past the effect itself.</a:t>
+            </a:r>
+          </a:p>
+          <a:p>
+            <a:r>
+              <a:rPr lang="en-GB" sz="1000" dirty="0"/>
+              <a:t>Here is the part worth remembering: the person affected is almost always the last one to notice. That is why the standard is fitness for work, and not just how you reckon you feel.</a:t>
+            </a:r>
+          </a:p>
+          <a:p>
+            <a:r>
+              <a:rPr lang="en-GB" sz="1000" b="1" dirty="0"/>
+              <a:t>ASK</a:t>
+            </a:r>
+          </a:p>
+          <a:p>
+            <a:r>
+              <a:rPr lang="en-GB" sz="1000" dirty="0"/>
+              <a:t>Think about the three jobs we named earlier. Which of those four would you least want to lose on that task?</a:t>
+            </a:r>
           </a:p>
         </p:txBody>
       </p:sp>
@@ -2162,13 +3303,63 @@
           <a:lstStyle/>
           <a:p>
             <a:r>
-              <a:rPr lang="en-US" dirty="0"/>
-              <a:t>Cue: read out only the testing types that actually apply here.
-Cue: say who owns the policy and where the full document can be read.
-Cue: say clearly that it applies to contractors and visitors too.
-Script booklet, section 6.</a:t>
-            </a:r>
-            <a:endParaRPr lang="en-US" dirty="0"/>
+              <a:rPr lang="en-GB" sz="1000" b="1" dirty="0"/>
+              <a:t>Our policy, the rules here · about 3 minutes</a:t>
+            </a:r>
+          </a:p>
+          <a:p>
+            <a:r>
+              <a:rPr lang="en-GB" sz="1000" b="1" dirty="0"/>
+              <a:t>SAY THIS</a:t>
+            </a:r>
+          </a:p>
+          <a:p>
+            <a:r>
+              <a:rPr lang="en-GB" sz="1000" dirty="0"/>
+              <a:t>This is our own document, so let me tell you what it actually says.</a:t>
+            </a:r>
+          </a:p>
+          <a:p>
+            <a:r>
+              <a:rPr lang="en-GB" sz="1000" dirty="0"/>
+              <a:t>The standard is fitness for work. Not abstinence in your private life — fitness for work when you are here. During working hours and paid breaks there is no alcohol and no drugs, and if a substance could be affecting you, you do not start.</a:t>
+            </a:r>
+          </a:p>
+          <a:p>
+            <a:r>
+              <a:rPr lang="en-GB" sz="1000" dirty="0"/>
+              <a:t>It applies to everyone on site, and that includes contractors and visitors. If you supervise contractors, that is worth knowing.</a:t>
+            </a:r>
+          </a:p>
+          <a:p>
+            <a:r>
+              <a:rPr lang="en-GB" sz="1000" dirty="0"/>
+              <a:t>The testing that applies here is ⟨Testing types in your policy⟩.</a:t>
+            </a:r>
+          </a:p>
+          <a:p>
+            <a:r>
+              <a:rPr lang="en-GB" sz="1000" dirty="0"/>
+              <a:t>The policy is strict about breaches and I am not going to soften that. What I will say is that the process before any of that happens is the one I am about to walk you through, and it is built so that decisions rest on evidence.</a:t>
+            </a:r>
+          </a:p>
+          <a:p>
+            <a:r>
+              <a:rPr lang="en-GB" sz="1000" dirty="0"/>
+              <a:t>⟨Policy owner⟩ owns the policy and the full document is at ⟨Where the policy is published⟩. Read it once today rather than for the first time on a bad day.</a:t>
+            </a:r>
+          </a:p>
+          <a:p>
+            <a:r>
+              <a:rPr lang="en-GB" sz="1000" b="1" dirty="0"/>
+              <a:t>DO</a:t>
+            </a:r>
+          </a:p>
+          <a:p>
+            <a:r>
+              <a:rPr lang="en-GB" sz="1000" dirty="0"/>
+              <a:t>Read out only the testing types that actually apply here. If there is no testing programme, say so plainly and say that people would be consulted first if that ever changed.</a:t>
+            </a:r>
           </a:p>
         </p:txBody>
       </p:sp>
@@ -2749,7 +3940,7 @@
                 <a:ea typeface="Open Sans" pitchFamily="34" charset="-122"/>
                 <a:cs typeface="Open Sans" pitchFamily="34" charset="-120"/>
               </a:rPr>
-              <a:t>Every ⟨angle bracket⟩ token in the slides, the delivery script and the sign-off sheet is filled in from your own policy before the talk.</a:t>
+              <a:t>Every ⟨angle bracket⟩ token in the slides, the speaker notes and the sign-off sheet is filled in from your own policy before the talk.</a:t>
             </a:r>
             <a:endParaRPr lang="en-US" sz="1400" dirty="0"/>
           </a:p>
@@ -2803,7 +3994,7 @@
         <p:spPr>
           <a:xfrm>
             <a:off x="1188720" y="2670048"/>
-            <a:ext cx="10134295" cy="740664"/>
+            <a:ext cx="10134295" cy="493776"/>
           </a:xfrm>
           <a:prstGeom prst="rect">
             <a:avLst/>
@@ -2847,7 +4038,7 @@
                 <a:ea typeface="Open Sans" pitchFamily="34" charset="-122"/>
                 <a:cs typeface="Open Sans" pitchFamily="34" charset="-120"/>
               </a:rPr>
-              <a:t>Two slides come in three versions — Northern Ireland, Republic of Ireland and Great Britain — each labelled in the top right corner. Keep the one that matches where you operate and delete the other two.</a:t>
+              <a:t>Two slides come in three versions — Northern Ireland, Republic of Ireland and Great Britain — labelled top right. Keep the one that matches where you operate and delete the other two.</a:t>
             </a:r>
             <a:endParaRPr lang="en-US" sz="1400" dirty="0"/>
           </a:p>
@@ -2861,7 +4052,7 @@
         </p:nvSpPr>
         <p:spPr>
           <a:xfrm>
-            <a:off x="777240" y="3593592"/>
+            <a:off x="777240" y="3346704"/>
             <a:ext cx="365760" cy="310896"/>
           </a:xfrm>
           <a:prstGeom prst="rect">
@@ -2900,7 +4091,7 @@
         </p:nvSpPr>
         <p:spPr>
           <a:xfrm>
-            <a:off x="1188720" y="3593592"/>
+            <a:off x="1188720" y="3346704"/>
             <a:ext cx="10134295" cy="246888"/>
           </a:xfrm>
           <a:prstGeom prst="rect">
@@ -2959,7 +4150,7 @@
         </p:nvSpPr>
         <p:spPr>
           <a:xfrm>
-            <a:off x="777240" y="4023360"/>
+            <a:off x="777240" y="3776472"/>
             <a:ext cx="365760" cy="310896"/>
           </a:xfrm>
           <a:prstGeom prst="rect">
@@ -2998,7 +4189,7 @@
         </p:nvSpPr>
         <p:spPr>
           <a:xfrm>
-            <a:off x="1188720" y="4023360"/>
+            <a:off x="1188720" y="3776472"/>
             <a:ext cx="10134295" cy="246888"/>
           </a:xfrm>
           <a:prstGeom prst="rect">
@@ -3057,7 +4248,7 @@
         </p:nvSpPr>
         <p:spPr>
           <a:xfrm>
-            <a:off x="777240" y="4453128"/>
+            <a:off x="777240" y="4206240"/>
             <a:ext cx="365760" cy="310896"/>
           </a:xfrm>
           <a:prstGeom prst="rect">
@@ -3096,7 +4287,7 @@
         </p:nvSpPr>
         <p:spPr>
           <a:xfrm>
-            <a:off x="1188720" y="4453128"/>
+            <a:off x="1188720" y="4206240"/>
             <a:ext cx="10134295" cy="493776"/>
           </a:xfrm>
           <a:prstGeom prst="rect">
@@ -3155,7 +4346,7 @@
         </p:nvSpPr>
         <p:spPr>
           <a:xfrm>
-            <a:off x="777240" y="5129784"/>
+            <a:off x="777240" y="4882896"/>
             <a:ext cx="365760" cy="310896"/>
           </a:xfrm>
           <a:prstGeom prst="rect">
@@ -3194,7 +4385,7 @@
         </p:nvSpPr>
         <p:spPr>
           <a:xfrm>
-            <a:off x="1188720" y="5129784"/>
+            <a:off x="1188720" y="4882896"/>
             <a:ext cx="10134295" cy="493776"/>
           </a:xfrm>
           <a:prstGeom prst="rect">
@@ -3523,7 +4714,7 @@
                 <a:ea typeface="Open Sans" pitchFamily="34" charset="-122"/>
                 <a:cs typeface="Open Sans" pitchFamily="34" charset="-120"/>
               </a:rPr>
-              <a:t>v1.0 — issued 11 August 2026 · prepared with NIVHA Laboratory Services · a template for the organisation to review and adopt — not legal advice</a:t>
+              <a:t>v1.1 — issued 2 September 2026 · prepared with NIVHA Laboratory Services · a template for the organisation to review and adopt — not legal advice</a:t>
             </a:r>
             <a:endParaRPr lang="en-US" sz="800" dirty="0"/>
           </a:p>
@@ -4150,7 +5341,7 @@
                 <a:ea typeface="Open Sans" pitchFamily="34" charset="-122"/>
                 <a:cs typeface="Open Sans" pitchFamily="34" charset="-120"/>
               </a:rPr>
-              <a:t>v1.0 — issued 11 August 2026 · prepared with NIVHA Laboratory Services · a template for the organisation to review and adopt — not legal advice</a:t>
+              <a:t>v1.1 — issued 2 September 2026 · prepared with NIVHA Laboratory Services · a template for the organisation to review and adopt — not legal advice</a:t>
             </a:r>
             <a:endParaRPr lang="en-US" sz="800" dirty="0"/>
           </a:p>
@@ -4721,7 +5912,7 @@
                 <a:ea typeface="Open Sans" pitchFamily="34" charset="-122"/>
                 <a:cs typeface="Open Sans" pitchFamily="34" charset="-120"/>
               </a:rPr>
-              <a:t>v1.0 — issued 11 August 2026 · prepared with NIVHA Laboratory Services · a template for the organisation to review and adopt — not legal advice</a:t>
+              <a:t>v1.1 — issued 2 September 2026 · prepared with NIVHA Laboratory Services · a template for the organisation to review and adopt — not legal advice</a:t>
             </a:r>
             <a:endParaRPr lang="en-US" sz="800" dirty="0"/>
           </a:p>
@@ -5330,7 +6521,7 @@
                 <a:ea typeface="Open Sans" pitchFamily="34" charset="-122"/>
                 <a:cs typeface="Open Sans" pitchFamily="34" charset="-120"/>
               </a:rPr>
-              <a:t>v1.0 — issued 11 August 2026 · prepared with NIVHA Laboratory Services · a template for the organisation to review and adopt — not legal advice</a:t>
+              <a:t>v1.1 — issued 2 September 2026 · prepared with NIVHA Laboratory Services · a template for the organisation to review and adopt — not legal advice</a:t>
             </a:r>
             <a:endParaRPr lang="en-US" sz="800" dirty="0"/>
           </a:p>
@@ -5939,7 +7130,7 @@
                 <a:ea typeface="Open Sans" pitchFamily="34" charset="-122"/>
                 <a:cs typeface="Open Sans" pitchFamily="34" charset="-120"/>
               </a:rPr>
-              <a:t>v1.0 — issued 11 August 2026 · prepared with NIVHA Laboratory Services · a template for the organisation to review and adopt — not legal advice</a:t>
+              <a:t>v1.1 — issued 2 September 2026 · prepared with NIVHA Laboratory Services · a template for the organisation to review and adopt — not legal advice</a:t>
             </a:r>
             <a:endParaRPr lang="en-US" sz="800" dirty="0"/>
           </a:p>
@@ -6803,7 +7994,7 @@
                 <a:ea typeface="Open Sans" pitchFamily="34" charset="-122"/>
                 <a:cs typeface="Open Sans" pitchFamily="34" charset="-120"/>
               </a:rPr>
-              <a:t>v1.0 — issued 11 August 2026 · prepared with NIVHA Laboratory Services · a template for the organisation to review and adopt — not legal advice</a:t>
+              <a:t>v1.1 — issued 2 September 2026 · prepared with NIVHA Laboratory Services · a template for the organisation to review and adopt — not legal advice</a:t>
             </a:r>
             <a:endParaRPr lang="en-US" sz="800" dirty="0"/>
           </a:p>
@@ -7550,7 +8741,7 @@
                 <a:ea typeface="Open Sans" pitchFamily="34" charset="-122"/>
                 <a:cs typeface="Open Sans" pitchFamily="34" charset="-120"/>
               </a:rPr>
-              <a:t>v1.0 — issued 11 August 2026 · prepared with NIVHA Laboratory Services · a template for the organisation to review and adopt — not legal advice</a:t>
+              <a:t>v1.1 — issued 2 September 2026 · prepared with NIVHA Laboratory Services · a template for the organisation to review and adopt — not legal advice</a:t>
             </a:r>
             <a:endParaRPr lang="en-US" sz="800" dirty="0"/>
           </a:p>
@@ -8297,7 +9488,7 @@
                 <a:ea typeface="Open Sans" pitchFamily="34" charset="-122"/>
                 <a:cs typeface="Open Sans" pitchFamily="34" charset="-120"/>
               </a:rPr>
-              <a:t>v1.0 — issued 11 August 2026 · prepared with NIVHA Laboratory Services · a template for the organisation to review and adopt — not legal advice</a:t>
+              <a:t>v1.1 — issued 2 September 2026 · prepared with NIVHA Laboratory Services · a template for the organisation to review and adopt — not legal advice</a:t>
             </a:r>
             <a:endParaRPr lang="en-US" sz="800" dirty="0"/>
           </a:p>
@@ -8867,7 +10058,7 @@
                 <a:ea typeface="Open Sans" pitchFamily="34" charset="-122"/>
                 <a:cs typeface="Open Sans" pitchFamily="34" charset="-120"/>
               </a:rPr>
-              <a:t>Hands up, answer read out straight after each one. Nothing is scored or recorded.</a:t>
+              <a:t>Hands up, with the answer read out straight after each one. Nothing is scored or recorded.</a:t>
             </a:r>
             <a:endParaRPr lang="en-US" sz="1500" dirty="0"/>
           </a:p>
@@ -8906,7 +10097,7 @@
                 <a:ea typeface="Open Sans" pitchFamily="34" charset="-122"/>
                 <a:cs typeface="Open Sans" pitchFamily="34" charset="-120"/>
               </a:rPr>
-              <a:t>v1.0 — issued 11 August 2026 · prepared with NIVHA Laboratory Services · a template for the organisation to review and adopt — not legal advice</a:t>
+              <a:t>v1.1 — issued 2 September 2026 · prepared with NIVHA Laboratory Services · a template for the organisation to review and adopt — not legal advice</a:t>
             </a:r>
             <a:endParaRPr lang="en-US" sz="800" dirty="0"/>
           </a:p>
@@ -8984,7 +10175,7 @@
                 <a:ea typeface="Open Sans" pitchFamily="34" charset="-122"/>
                 <a:cs typeface="Open Sans" pitchFamily="34" charset="-120"/>
               </a:rPr>
-              <a:t>What single question is the policy asking about you?</a:t>
+              <a:t>What single question is the policy asking of you?</a:t>
             </a:r>
             <a:endParaRPr lang="en-US" sz="1400" dirty="0"/>
           </a:p>
@@ -9179,7 +10370,7 @@
                 <a:ea typeface="Open Sans" pitchFamily="34" charset="-122"/>
                 <a:cs typeface="Open Sans" pitchFamily="34" charset="-120"/>
               </a:rPr>
-              <a:t>Answers are in the speaker notes and in the delivery script booklet.</a:t>
+              <a:t>Answers are in the speaker notes for this slide.</a:t>
             </a:r>
             <a:endParaRPr lang="en-US" sz="1150" dirty="0"/>
           </a:p>
@@ -9270,7 +10461,7 @@
                 <a:ea typeface="Open Sans" pitchFamily="34" charset="-122"/>
                 <a:cs typeface="Open Sans" pitchFamily="34" charset="-120"/>
               </a:rPr>
-              <a:t>v1.0 — issued 11 August 2026 · prepared with NIVHA Laboratory Services · a template for the organisation to review and adopt — not legal advice</a:t>
+              <a:t>v1.1 — issued 2 September 2026 · prepared with NIVHA Laboratory Services · a template for the organisation to review and adopt — not legal advice</a:t>
             </a:r>
             <a:endParaRPr lang="en-US" sz="800" dirty="0"/>
           </a:p>
@@ -9417,7 +10608,7 @@
                 <a:ea typeface="Open Sans" pitchFamily="34" charset="-122"/>
                 <a:cs typeface="Open Sans" pitchFamily="34" charset="-120"/>
               </a:rPr>
-              <a:t>The policy asks one question: are you fit to do your work safely today</a:t>
+              <a:t>The policy asks one question: are you fit to do your work safely today?</a:t>
             </a:r>
             <a:endParaRPr lang="en-US" sz="1350" dirty="0"/>
           </a:p>
@@ -9622,7 +10813,7 @@
                 <a:ea typeface="Open Sans" pitchFamily="34" charset="-122"/>
                 <a:cs typeface="Open Sans" pitchFamily="34" charset="-120"/>
               </a:rPr>
-              <a:t>v1.0 — issued 11 August 2026 · prepared with NIVHA Laboratory Services · a template for the organisation to review and adopt — not legal advice</a:t>
+              <a:t>v1.1 — issued 2 September 2026 · prepared with NIVHA Laboratory Services · a template for the organisation to review and adopt — not legal advice</a:t>
             </a:r>
             <a:endParaRPr lang="en-US" sz="800" dirty="0"/>
           </a:p>
@@ -9900,7 +11091,7 @@
                 <a:ea typeface="Open Sans" pitchFamily="34" charset="-122"/>
                 <a:cs typeface="Open Sans" pitchFamily="34" charset="-120"/>
               </a:rPr>
-              <a:t>Sign-off sheet and delivery script accompany this deck.</a:t>
+              <a:t>Sign-off sheet accompanies this deck. The full delivery script is in the speaker notes.</a:t>
             </a:r>
             <a:endParaRPr lang="en-US" sz="1150" dirty="0"/>
           </a:p>
@@ -10252,7 +11443,7 @@
                 <a:ea typeface="Open Sans" pitchFamily="34" charset="-122"/>
                 <a:cs typeface="Open Sans" pitchFamily="34" charset="-120"/>
               </a:rPr>
-              <a:t>v1.0 — issued 11 August 2026 · prepared with NIVHA Laboratory Services · a template for the organisation to review and adopt — not legal advice</a:t>
+              <a:t>v1.1 — issued 2 September 2026 · prepared with NIVHA Laboratory Services · a template for the organisation to review and adopt — not legal advice</a:t>
             </a:r>
             <a:endParaRPr lang="en-US" sz="800" dirty="0"/>
           </a:p>
@@ -10294,7 +11485,7 @@
                 <a:ea typeface="Open Sans SemiBold" pitchFamily="34" charset="-122"/>
                 <a:cs typeface="Open Sans SemiBold" pitchFamily="34" charset="-120"/>
               </a:rPr>
-              <a:t>The policy asks one question: are you fit to do your work safely today.</a:t>
+              <a:t>The policy asks one question: are you fit to do your work safely today?</a:t>
             </a:r>
             <a:endParaRPr lang="en-US" sz="2500" dirty="0"/>
           </a:p>
@@ -10946,7 +12137,7 @@
                 <a:ea typeface="Open Sans" pitchFamily="34" charset="-122"/>
                 <a:cs typeface="Open Sans" pitchFamily="34" charset="-120"/>
               </a:rPr>
-              <a:t>v1.0 — issued 11 August 2026 · prepared with NIVHA Laboratory Services · a template for the organisation to review and adopt — not legal advice</a:t>
+              <a:t>v1.1 — issued 2 September 2026 · prepared with NIVHA Laboratory Services · a template for the organisation to review and adopt — not legal advice</a:t>
             </a:r>
             <a:endParaRPr lang="en-US" sz="800" dirty="0"/>
           </a:p>
@@ -11622,7 +12813,7 @@
                 <a:ea typeface="Open Sans" pitchFamily="34" charset="-122"/>
                 <a:cs typeface="Open Sans" pitchFamily="34" charset="-120"/>
               </a:rPr>
-              <a:t>v1.0 — issued 11 August 2026 · prepared with NIVHA Laboratory Services · a template for the organisation to review and adopt — not legal advice</a:t>
+              <a:t>v1.1 — issued 2 September 2026 · prepared with NIVHA Laboratory Services · a template for the organisation to review and adopt — not legal advice</a:t>
             </a:r>
             <a:endParaRPr lang="en-US" sz="800" dirty="0"/>
           </a:p>
@@ -12228,7 +13419,7 @@
                 <a:ea typeface="Open Sans" pitchFamily="34" charset="-122"/>
                 <a:cs typeface="Open Sans" pitchFamily="34" charset="-120"/>
               </a:rPr>
-              <a:t>v1.0 — issued 11 August 2026 · prepared with NIVHA Laboratory Services · a template for the organisation to review and adopt — not legal advice</a:t>
+              <a:t>v1.1 — issued 2 September 2026 · prepared with NIVHA Laboratory Services · a template for the organisation to review and adopt — not legal advice</a:t>
             </a:r>
             <a:endParaRPr lang="en-US" sz="800" dirty="0"/>
           </a:p>
@@ -12774,7 +13965,7 @@
                 <a:ea typeface="Open Sans" pitchFamily="34" charset="-122"/>
                 <a:cs typeface="Open Sans" pitchFamily="34" charset="-120"/>
               </a:rPr>
-              <a:t>v1.0 — issued 11 August 2026 · prepared with NIVHA Laboratory Services · a template for the organisation to review and adopt — not legal advice</a:t>
+              <a:t>v1.1 — issued 2 September 2026 · prepared with NIVHA Laboratory Services · a template for the organisation to review and adopt — not legal advice</a:t>
             </a:r>
             <a:endParaRPr lang="en-US" sz="800" dirty="0"/>
           </a:p>
@@ -13443,7 +14634,7 @@
                 <a:ea typeface="Open Sans" pitchFamily="34" charset="-122"/>
                 <a:cs typeface="Open Sans" pitchFamily="34" charset="-120"/>
               </a:rPr>
-              <a:t>v1.0 — issued 11 August 2026 · prepared with NIVHA Laboratory Services · a template for the organisation to review and adopt — not legal advice</a:t>
+              <a:t>v1.1 — issued 2 September 2026 · prepared with NIVHA Laboratory Services · a template for the organisation to review and adopt — not legal advice</a:t>
             </a:r>
             <a:endParaRPr lang="en-US" sz="800" dirty="0"/>
           </a:p>
@@ -14091,7 +15282,7 @@
                 <a:ea typeface="Open Sans" pitchFamily="34" charset="-122"/>
                 <a:cs typeface="Open Sans" pitchFamily="34" charset="-120"/>
               </a:rPr>
-              <a:t>v1.0 — issued 11 August 2026 · prepared with NIVHA Laboratory Services · a template for the organisation to review and adopt — not legal advice</a:t>
+              <a:t>v1.1 — issued 2 September 2026 · prepared with NIVHA Laboratory Services · a template for the organisation to review and adopt — not legal advice</a:t>
             </a:r>
             <a:endParaRPr lang="en-US" sz="800" dirty="0"/>
           </a:p>

</xml_diff>